<commit_message>
last? preparations for first day of python bootcamp
</commit_message>
<xml_diff>
--- a/day1/slides/context.pptx
+++ b/day1/slides/context.pptx
@@ -204,7 +204,7 @@
           <a:p>
             <a:fld id="{5450099C-8BB7-944A-BC72-CA2F6E7F4B31}" type="datetimeFigureOut">
               <a:rPr lang="en-US" smtClean="0"/>
-              <a:t>5/5/23</a:t>
+              <a:t>5/10/26</a:t>
             </a:fld>
             <a:endParaRPr lang="en-US"/>
           </a:p>
@@ -1123,6 +1123,13 @@
             <a:schemeClr val="lt1"/>
           </a:fontRef>
         </p:style>
+        <p:txBody>
+          <a:bodyPr/>
+          <a:lstStyle/>
+          <a:p>
+            <a:endParaRPr lang="en-US"/>
+          </a:p>
+        </p:txBody>
       </p:sp>
       <p:sp>
         <p:nvSpPr>
@@ -1161,6 +1168,13 @@
             <a:schemeClr val="lt1"/>
           </a:fontRef>
         </p:style>
+        <p:txBody>
+          <a:bodyPr/>
+          <a:lstStyle/>
+          <a:p>
+            <a:endParaRPr lang="en-US"/>
+          </a:p>
+        </p:txBody>
       </p:sp>
       <p:sp>
         <p:nvSpPr>
@@ -1282,7 +1296,7 @@
           <a:p>
             <a:fld id="{51673806-0BCD-1F42-BAA8-2011034B3C6A}" type="datetimeFigureOut">
               <a:rPr lang="en-US" smtClean="0"/>
-              <a:t>5/5/23</a:t>
+              <a:t>5/10/26</a:t>
             </a:fld>
             <a:endParaRPr lang="en-US"/>
           </a:p>
@@ -1696,7 +1710,7 @@
           <a:p>
             <a:fld id="{51673806-0BCD-1F42-BAA8-2011034B3C6A}" type="datetimeFigureOut">
               <a:rPr lang="en-US" smtClean="0"/>
-              <a:t>5/5/23</a:t>
+              <a:t>5/10/26</a:t>
             </a:fld>
             <a:endParaRPr lang="en-US"/>
           </a:p>
@@ -2027,7 +2041,7 @@
           <a:p>
             <a:fld id="{51673806-0BCD-1F42-BAA8-2011034B3C6A}" type="datetimeFigureOut">
               <a:rPr lang="en-US" smtClean="0"/>
-              <a:t>5/5/23</a:t>
+              <a:t>5/10/26</a:t>
             </a:fld>
             <a:endParaRPr lang="en-US"/>
           </a:p>
@@ -2427,7 +2441,7 @@
           <a:p>
             <a:fld id="{51673806-0BCD-1F42-BAA8-2011034B3C6A}" type="datetimeFigureOut">
               <a:rPr lang="en-US" smtClean="0"/>
-              <a:t>5/5/23</a:t>
+              <a:t>5/10/26</a:t>
             </a:fld>
             <a:endParaRPr lang="en-US"/>
           </a:p>
@@ -2990,7 +3004,7 @@
           <a:p>
             <a:fld id="{51673806-0BCD-1F42-BAA8-2011034B3C6A}" type="datetimeFigureOut">
               <a:rPr lang="en-US" smtClean="0"/>
-              <a:t>5/5/23</a:t>
+              <a:t>5/10/26</a:t>
             </a:fld>
             <a:endParaRPr lang="en-US"/>
           </a:p>
@@ -3666,7 +3680,7 @@
           <a:p>
             <a:fld id="{51673806-0BCD-1F42-BAA8-2011034B3C6A}" type="datetimeFigureOut">
               <a:rPr lang="en-US" smtClean="0"/>
-              <a:t>5/5/23</a:t>
+              <a:t>5/10/26</a:t>
             </a:fld>
             <a:endParaRPr lang="en-US"/>
           </a:p>
@@ -4574,7 +4588,7 @@
           <a:p>
             <a:fld id="{51673806-0BCD-1F42-BAA8-2011034B3C6A}" type="datetimeFigureOut">
               <a:rPr lang="en-US" smtClean="0"/>
-              <a:t>5/5/23</a:t>
+              <a:t>5/10/26</a:t>
             </a:fld>
             <a:endParaRPr lang="en-US"/>
           </a:p>
@@ -4882,7 +4896,7 @@
           <a:p>
             <a:fld id="{51673806-0BCD-1F42-BAA8-2011034B3C6A}" type="datetimeFigureOut">
               <a:rPr lang="en-US" smtClean="0"/>
-              <a:t>5/5/23</a:t>
+              <a:t>5/10/26</a:t>
             </a:fld>
             <a:endParaRPr lang="en-US"/>
           </a:p>
@@ -5141,7 +5155,7 @@
           <a:p>
             <a:fld id="{51673806-0BCD-1F42-BAA8-2011034B3C6A}" type="datetimeFigureOut">
               <a:rPr lang="en-US" smtClean="0"/>
-              <a:t>5/5/23</a:t>
+              <a:t>5/10/26</a:t>
             </a:fld>
             <a:endParaRPr lang="en-US"/>
           </a:p>
@@ -5464,7 +5478,7 @@
           <a:p>
             <a:fld id="{51673806-0BCD-1F42-BAA8-2011034B3C6A}" type="datetimeFigureOut">
               <a:rPr lang="en-US" smtClean="0"/>
-              <a:t>5/5/23</a:t>
+              <a:t>5/10/26</a:t>
             </a:fld>
             <a:endParaRPr lang="en-US"/>
           </a:p>
@@ -5848,7 +5862,7 @@
           <a:p>
             <a:fld id="{51673806-0BCD-1F42-BAA8-2011034B3C6A}" type="datetimeFigureOut">
               <a:rPr lang="en-US" smtClean="0"/>
-              <a:t>5/5/23</a:t>
+              <a:t>5/10/26</a:t>
             </a:fld>
             <a:endParaRPr lang="en-US"/>
           </a:p>
@@ -6224,7 +6238,7 @@
           <a:p>
             <a:fld id="{51673806-0BCD-1F42-BAA8-2011034B3C6A}" type="datetimeFigureOut">
               <a:rPr lang="en-US" smtClean="0"/>
-              <a:t>5/5/23</a:t>
+              <a:t>5/10/26</a:t>
             </a:fld>
             <a:endParaRPr lang="en-US"/>
           </a:p>
@@ -6730,7 +6744,7 @@
           <a:p>
             <a:fld id="{51673806-0BCD-1F42-BAA8-2011034B3C6A}" type="datetimeFigureOut">
               <a:rPr lang="en-US" smtClean="0"/>
-              <a:t>5/5/23</a:t>
+              <a:t>5/10/26</a:t>
             </a:fld>
             <a:endParaRPr lang="en-US"/>
           </a:p>
@@ -6987,7 +7001,7 @@
           <a:p>
             <a:fld id="{51673806-0BCD-1F42-BAA8-2011034B3C6A}" type="datetimeFigureOut">
               <a:rPr lang="en-US" smtClean="0"/>
-              <a:t>5/5/23</a:t>
+              <a:t>5/10/26</a:t>
             </a:fld>
             <a:endParaRPr lang="en-US"/>
           </a:p>
@@ -7145,7 +7159,7 @@
           <a:p>
             <a:fld id="{51673806-0BCD-1F42-BAA8-2011034B3C6A}" type="datetimeFigureOut">
               <a:rPr lang="en-US" smtClean="0"/>
-              <a:t>5/5/23</a:t>
+              <a:t>5/10/26</a:t>
             </a:fld>
             <a:endParaRPr lang="en-US"/>
           </a:p>
@@ -7535,7 +7549,7 @@
           <a:p>
             <a:fld id="{51673806-0BCD-1F42-BAA8-2011034B3C6A}" type="datetimeFigureOut">
               <a:rPr lang="en-US" smtClean="0"/>
-              <a:t>5/5/23</a:t>
+              <a:t>5/10/26</a:t>
             </a:fld>
             <a:endParaRPr lang="en-US"/>
           </a:p>
@@ -7944,7 +7958,7 @@
           <a:p>
             <a:fld id="{51673806-0BCD-1F42-BAA8-2011034B3C6A}" type="datetimeFigureOut">
               <a:rPr lang="en-US" smtClean="0"/>
-              <a:t>5/5/23</a:t>
+              <a:t>5/10/26</a:t>
             </a:fld>
             <a:endParaRPr lang="en-US"/>
           </a:p>
@@ -8190,7 +8204,7 @@
             <a:fld id="{51673806-0BCD-1F42-BAA8-2011034B3C6A}" type="datetimeFigureOut">
               <a:rPr lang="en-US" smtClean="0"/>
               <a:pPr/>
-              <a:t>5/5/23</a:t>
+              <a:t>5/10/26</a:t>
             </a:fld>
             <a:endParaRPr lang="en-US" dirty="0"/>
           </a:p>
@@ -9885,40 +9899,29 @@
           <a:p>
             <a:r>
               <a:rPr lang="en-US" dirty="0"/>
-              <a:t>Example: </a:t>
-            </a:r>
-            <a:r>
-              <a:rPr lang="en-US" dirty="0" err="1"/>
-              <a:t>var</a:t>
-            </a:r>
-            <a:r>
-              <a:rPr lang="en-US" dirty="0"/>
-              <a:t> x = 3;</a:t>
+              <a:t>Example: let x = 3;</a:t>
             </a:r>
             <a:br>
               <a:rPr lang="en-US" dirty="0"/>
             </a:br>
             <a:r>
               <a:rPr lang="en-US" dirty="0"/>
-              <a:t>	       </a:t>
-            </a:r>
-            <a:r>
-              <a:rPr lang="en-US" dirty="0" err="1"/>
-              <a:t>var</a:t>
-            </a:r>
+              <a:t>	       let y = “4”;</a:t>
+            </a:r>
+          </a:p>
+          <a:p>
+            <a:endParaRPr lang="en-US" dirty="0"/>
+          </a:p>
+          <a:p>
             <a:r>
               <a:rPr lang="en-US" dirty="0"/>
-              <a:t> y = “4”;</a:t>
-            </a:r>
-          </a:p>
-          <a:p>
+              <a:t>JS makes “best guesses” on how to interpret data (and often has weird </a:t>
+            </a:r>
+            <a:r>
+              <a:rPr lang="en-US"/>
+              <a:t>unexpected behavior)</a:t>
+            </a:r>
             <a:endParaRPr lang="en-US" dirty="0"/>
-          </a:p>
-          <a:p>
-            <a:r>
-              <a:rPr lang="en-US" dirty="0"/>
-              <a:t>JS makes more “best guesses” on how to interpret data than Python</a:t>
-            </a:r>
           </a:p>
           <a:p>
             <a:pPr lvl="1"/>

</xml_diff>

<commit_message>
more prep for first presentation
</commit_message>
<xml_diff>
--- a/day1/slides/context.pptx
+++ b/day1/slides/context.pptx
@@ -204,7 +204,7 @@
           <a:p>
             <a:fld id="{5450099C-8BB7-944A-BC72-CA2F6E7F4B31}" type="datetimeFigureOut">
               <a:rPr lang="en-US" smtClean="0"/>
-              <a:t>5/10/26</a:t>
+              <a:t>5/11/26</a:t>
             </a:fld>
             <a:endParaRPr lang="en-US"/>
           </a:p>
@@ -517,7 +517,7 @@
           <a:p>
             <a:r>
               <a:rPr lang="en-US" dirty="0"/>
-              <a:t>This next set of slides is just kind of going to be putting Python into the context of other programming languages and kind of the mechanics behind it. C++ I think is what OSU really pushes in classes, so we’ll kind of compare it to Python to help better put that into context for those of you who have coded before.</a:t>
+              <a:t>This next set of slides is just kind of going to be putting Python into the context of other programming languages and kind of the mechanics behind it. C++ I think is what OSU really pushes in classes, so we’ll kind of compare it to Python to help better put that into context for those of you who have coded before. Note from Jackson: at least in computer science land, java is pushed for people new to programing. Then you will learn stuff in C for systems.</a:t>
             </a:r>
           </a:p>
         </p:txBody>
@@ -1296,7 +1296,7 @@
           <a:p>
             <a:fld id="{51673806-0BCD-1F42-BAA8-2011034B3C6A}" type="datetimeFigureOut">
               <a:rPr lang="en-US" smtClean="0"/>
-              <a:t>5/10/26</a:t>
+              <a:t>5/11/26</a:t>
             </a:fld>
             <a:endParaRPr lang="en-US"/>
           </a:p>
@@ -1710,7 +1710,7 @@
           <a:p>
             <a:fld id="{51673806-0BCD-1F42-BAA8-2011034B3C6A}" type="datetimeFigureOut">
               <a:rPr lang="en-US" smtClean="0"/>
-              <a:t>5/10/26</a:t>
+              <a:t>5/11/26</a:t>
             </a:fld>
             <a:endParaRPr lang="en-US"/>
           </a:p>
@@ -2041,7 +2041,7 @@
           <a:p>
             <a:fld id="{51673806-0BCD-1F42-BAA8-2011034B3C6A}" type="datetimeFigureOut">
               <a:rPr lang="en-US" smtClean="0"/>
-              <a:t>5/10/26</a:t>
+              <a:t>5/11/26</a:t>
             </a:fld>
             <a:endParaRPr lang="en-US"/>
           </a:p>
@@ -2441,7 +2441,7 @@
           <a:p>
             <a:fld id="{51673806-0BCD-1F42-BAA8-2011034B3C6A}" type="datetimeFigureOut">
               <a:rPr lang="en-US" smtClean="0"/>
-              <a:t>5/10/26</a:t>
+              <a:t>5/11/26</a:t>
             </a:fld>
             <a:endParaRPr lang="en-US"/>
           </a:p>
@@ -3004,7 +3004,7 @@
           <a:p>
             <a:fld id="{51673806-0BCD-1F42-BAA8-2011034B3C6A}" type="datetimeFigureOut">
               <a:rPr lang="en-US" smtClean="0"/>
-              <a:t>5/10/26</a:t>
+              <a:t>5/11/26</a:t>
             </a:fld>
             <a:endParaRPr lang="en-US"/>
           </a:p>
@@ -3680,7 +3680,7 @@
           <a:p>
             <a:fld id="{51673806-0BCD-1F42-BAA8-2011034B3C6A}" type="datetimeFigureOut">
               <a:rPr lang="en-US" smtClean="0"/>
-              <a:t>5/10/26</a:t>
+              <a:t>5/11/26</a:t>
             </a:fld>
             <a:endParaRPr lang="en-US"/>
           </a:p>
@@ -4588,7 +4588,7 @@
           <a:p>
             <a:fld id="{51673806-0BCD-1F42-BAA8-2011034B3C6A}" type="datetimeFigureOut">
               <a:rPr lang="en-US" smtClean="0"/>
-              <a:t>5/10/26</a:t>
+              <a:t>5/11/26</a:t>
             </a:fld>
             <a:endParaRPr lang="en-US"/>
           </a:p>
@@ -4896,7 +4896,7 @@
           <a:p>
             <a:fld id="{51673806-0BCD-1F42-BAA8-2011034B3C6A}" type="datetimeFigureOut">
               <a:rPr lang="en-US" smtClean="0"/>
-              <a:t>5/10/26</a:t>
+              <a:t>5/11/26</a:t>
             </a:fld>
             <a:endParaRPr lang="en-US"/>
           </a:p>
@@ -5155,7 +5155,7 @@
           <a:p>
             <a:fld id="{51673806-0BCD-1F42-BAA8-2011034B3C6A}" type="datetimeFigureOut">
               <a:rPr lang="en-US" smtClean="0"/>
-              <a:t>5/10/26</a:t>
+              <a:t>5/11/26</a:t>
             </a:fld>
             <a:endParaRPr lang="en-US"/>
           </a:p>
@@ -5478,7 +5478,7 @@
           <a:p>
             <a:fld id="{51673806-0BCD-1F42-BAA8-2011034B3C6A}" type="datetimeFigureOut">
               <a:rPr lang="en-US" smtClean="0"/>
-              <a:t>5/10/26</a:t>
+              <a:t>5/11/26</a:t>
             </a:fld>
             <a:endParaRPr lang="en-US"/>
           </a:p>
@@ -5862,7 +5862,7 @@
           <a:p>
             <a:fld id="{51673806-0BCD-1F42-BAA8-2011034B3C6A}" type="datetimeFigureOut">
               <a:rPr lang="en-US" smtClean="0"/>
-              <a:t>5/10/26</a:t>
+              <a:t>5/11/26</a:t>
             </a:fld>
             <a:endParaRPr lang="en-US"/>
           </a:p>
@@ -6238,7 +6238,7 @@
           <a:p>
             <a:fld id="{51673806-0BCD-1F42-BAA8-2011034B3C6A}" type="datetimeFigureOut">
               <a:rPr lang="en-US" smtClean="0"/>
-              <a:t>5/10/26</a:t>
+              <a:t>5/11/26</a:t>
             </a:fld>
             <a:endParaRPr lang="en-US"/>
           </a:p>
@@ -6744,7 +6744,7 @@
           <a:p>
             <a:fld id="{51673806-0BCD-1F42-BAA8-2011034B3C6A}" type="datetimeFigureOut">
               <a:rPr lang="en-US" smtClean="0"/>
-              <a:t>5/10/26</a:t>
+              <a:t>5/11/26</a:t>
             </a:fld>
             <a:endParaRPr lang="en-US"/>
           </a:p>
@@ -7001,7 +7001,7 @@
           <a:p>
             <a:fld id="{51673806-0BCD-1F42-BAA8-2011034B3C6A}" type="datetimeFigureOut">
               <a:rPr lang="en-US" smtClean="0"/>
-              <a:t>5/10/26</a:t>
+              <a:t>5/11/26</a:t>
             </a:fld>
             <a:endParaRPr lang="en-US"/>
           </a:p>
@@ -7159,7 +7159,7 @@
           <a:p>
             <a:fld id="{51673806-0BCD-1F42-BAA8-2011034B3C6A}" type="datetimeFigureOut">
               <a:rPr lang="en-US" smtClean="0"/>
-              <a:t>5/10/26</a:t>
+              <a:t>5/11/26</a:t>
             </a:fld>
             <a:endParaRPr lang="en-US"/>
           </a:p>
@@ -7549,7 +7549,7 @@
           <a:p>
             <a:fld id="{51673806-0BCD-1F42-BAA8-2011034B3C6A}" type="datetimeFigureOut">
               <a:rPr lang="en-US" smtClean="0"/>
-              <a:t>5/10/26</a:t>
+              <a:t>5/11/26</a:t>
             </a:fld>
             <a:endParaRPr lang="en-US"/>
           </a:p>
@@ -7958,7 +7958,7 @@
           <a:p>
             <a:fld id="{51673806-0BCD-1F42-BAA8-2011034B3C6A}" type="datetimeFigureOut">
               <a:rPr lang="en-US" smtClean="0"/>
-              <a:t>5/10/26</a:t>
+              <a:t>5/11/26</a:t>
             </a:fld>
             <a:endParaRPr lang="en-US"/>
           </a:p>
@@ -8204,7 +8204,7 @@
             <a:fld id="{51673806-0BCD-1F42-BAA8-2011034B3C6A}" type="datetimeFigureOut">
               <a:rPr lang="en-US" smtClean="0"/>
               <a:pPr/>
-              <a:t>5/10/26</a:t>
+              <a:t>5/11/26</a:t>
             </a:fld>
             <a:endParaRPr lang="en-US" dirty="0"/>
           </a:p>
@@ -9054,7 +9054,7 @@
           <a:p>
             <a:r>
               <a:rPr lang="en-US" dirty="0"/>
-              <a:t>Programs are “translated” to machine language, and </a:t>
+              <a:t>Programs are “compiled” to machine language, and </a:t>
             </a:r>
             <a:r>
               <a:rPr lang="en-US" i="1" dirty="0"/>
@@ -9062,7 +9062,7 @@
             </a:r>
             <a:r>
               <a:rPr lang="en-US" dirty="0"/>
-              <a:t> ran</a:t>
+              <a:t> run</a:t>
             </a:r>
           </a:p>
           <a:p>
@@ -9071,7 +9071,7 @@
           <a:p>
             <a:r>
               <a:rPr lang="en-US" dirty="0"/>
-              <a:t>Difficult to write </a:t>
+              <a:t>Can be difficult to write</a:t>
             </a:r>
           </a:p>
           <a:p>
@@ -9234,7 +9234,7 @@
             </a:r>
             <a:r>
               <a:rPr lang="en-US" dirty="0"/>
-              <a:t> </a:t>
+              <a:t> (NumPy already does this for you!)</a:t>
             </a:r>
           </a:p>
           <a:p>
@@ -9337,7 +9337,9 @@
           </a:xfrm>
         </p:spPr>
         <p:txBody>
-          <a:bodyPr/>
+          <a:bodyPr>
+            <a:normAutofit lnSpcReduction="10000"/>
+          </a:bodyPr>
           <a:lstStyle/>
           <a:p>
             <a:pPr marL="0" indent="0">
@@ -9361,6 +9363,13 @@
             <a:r>
               <a:rPr lang="en-US" dirty="0"/>
               <a:t>This is part of what makes python a slower language </a:t>
+            </a:r>
+          </a:p>
+          <a:p>
+            <a:pPr lvl="1"/>
+            <a:r>
+              <a:rPr lang="en-US" dirty="0"/>
+              <a:t>This is common in high level interpreted programming languages</a:t>
             </a:r>
           </a:p>
           <a:p>

</xml_diff>